<commit_message>
Mise a jour PowerPoint
</commit_message>
<xml_diff>
--- a/Présentation.pptx
+++ b/Présentation.pptx
@@ -3888,7 +3888,7 @@
       </p:grpSpPr>
       <p:sp>
         <p:nvSpPr>
-          <p:cNvPr id="54" name="PlaceHolder 1"/>
+          <p:cNvPr id="52" name="PlaceHolder 1"/>
           <p:cNvSpPr>
             <a:spLocks noGrp="1"/>
           </p:cNvSpPr>
@@ -3898,8 +3898,8 @@
         </p:nvSpPr>
         <p:spPr>
           <a:xfrm>
-            <a:off x="2846520" y="304920"/>
-            <a:ext cx="6498360" cy="628920"/>
+            <a:off x="3025800" y="304920"/>
+            <a:ext cx="6139800" cy="628920"/>
           </a:xfrm>
           <a:prstGeom prst="rect">
             <a:avLst/>
@@ -3945,6 +3945,313 @@
               <a:uFillTx/>
               <a:latin typeface="Calibri"/>
             </a:endParaRPr>
+          </a:p>
+        </p:txBody>
+      </p:sp>
+      <p:sp>
+        <p:nvSpPr>
+          <p:cNvPr id="53" name="ZoneTexte 53"/>
+          <p:cNvSpPr/>
+          <p:nvPr/>
+        </p:nvSpPr>
+        <p:spPr>
+          <a:xfrm>
+            <a:off x="609480" y="1400000"/>
+            <a:ext cx="10900000" cy="2600000"/>
+          </a:xfrm>
+          <a:prstGeom prst="rect">
+            <a:avLst/>
+          </a:prstGeom>
+          <a:noFill/>
+          <a:ln w="0">
+            <a:noFill/>
+          </a:ln>
+        </p:spPr>
+        <p:style>
+          <a:lnRef idx="0"/>
+          <a:fillRef idx="0"/>
+          <a:effectRef idx="0"/>
+          <a:fontRef idx="minor"/>
+        </p:style>
+        <p:txBody>
+          <a:bodyPr lIns="90000" tIns="45000" rIns="90000" bIns="45000" anchor="t">
+            <a:spAutoFit/>
+          </a:bodyPr>
+          <a:p>
+            <a:pPr marL="285840" indent="-285840">
+              <a:lnSpc>
+                <a:spcPct val="100000"/>
+              </a:lnSpc>
+              <a:buClr>
+                <a:srgbClr val="FFFFFF"/>
+              </a:buClr>
+              <a:buFont typeface="OpenSymbol"/>
+              <a:buChar char="-"/>
+            </a:pPr>
+            <a:r>
+              <a:rPr lang="fr-FR" sz="1500" b="1" u="none" strike="noStrike">
+                <a:solidFill>
+                  <a:schemeClr val="lt1"/>
+                </a:solidFill>
+                <a:effectLst/>
+                <a:uFillTx/>
+                <a:latin typeface="Arial"/>
+              </a:rPr>
+              <a:t>Source : </a:t>
+            </a:r>
+            <a:r>
+              <a:rPr lang="fr-FR" sz="1500" b="0" u="none" strike="noStrike">
+                <a:solidFill>
+                  <a:schemeClr val="lt1"/>
+                </a:solidFill>
+                <a:effectLst/>
+                <a:uFillTx/>
+                <a:latin typeface="Arial"/>
+              </a:rPr>
+              <a:t>ruche de registre SYSTEM, clé ControlSet001\Enum\USBSTOR, lue avec Registry Explorer v2026.5.0</a:t>
+            </a:r>
+            <a:endParaRPr lang="en-GB" sz="1500" b="0" u="none" strike="noStrike">
+              <a:solidFill>
+                <a:srgbClr val="000000"/>
+              </a:solidFill>
+              <a:effectLst/>
+              <a:uFillTx/>
+              <a:latin typeface="Arial"/>
+            </a:endParaRPr>
+          </a:p>
+          <a:p>
+            <a:pPr>
+              <a:lnSpc>
+                <a:spcPct val="100000"/>
+              </a:lnSpc>
+            </a:pPr>
+            <a:endParaRPr lang="en-GB" sz="1500" b="0" u="none" strike="noStrike">
+              <a:solidFill>
+                <a:srgbClr val="000000"/>
+              </a:solidFill>
+              <a:effectLst/>
+              <a:uFillTx/>
+              <a:latin typeface="Arial"/>
+            </a:endParaRPr>
+          </a:p>
+          <a:p>
+            <a:pPr marL="285840" indent="-285840">
+              <a:lnSpc>
+                <a:spcPct val="100000"/>
+              </a:lnSpc>
+              <a:buClr>
+                <a:srgbClr val="FFFFFF"/>
+              </a:buClr>
+              <a:buFont typeface="OpenSymbol"/>
+              <a:buChar char="-"/>
+            </a:pPr>
+            <a:r>
+              <a:rPr lang="fr-FR" sz="1500" b="1" u="none" strike="noStrike">
+                <a:solidFill>
+                  <a:schemeClr val="lt1"/>
+                </a:solidFill>
+                <a:effectLst/>
+                <a:uFillTx/>
+                <a:latin typeface="Arial"/>
+              </a:rPr>
+              <a:t>Périphérique identifié : </a:t>
+            </a:r>
+            <a:r>
+              <a:rPr lang="fr-FR" sz="1500" b="0" u="none" strike="noStrike">
+                <a:solidFill>
+                  <a:schemeClr val="lt1"/>
+                </a:solidFill>
+                <a:effectLst/>
+                <a:uFillTx/>
+                <a:latin typeface="Arial"/>
+              </a:rPr>
+              <a:t>SanDisk Cruzer Blade USB Device (Ven_SanDisk, Prod_Cruzer_Blade, Rev_1.00)</a:t>
+            </a:r>
+            <a:endParaRPr lang="en-GB" sz="1500" b="0" u="none" strike="noStrike">
+              <a:solidFill>
+                <a:srgbClr val="000000"/>
+              </a:solidFill>
+              <a:effectLst/>
+              <a:uFillTx/>
+              <a:latin typeface="Arial"/>
+            </a:endParaRPr>
+          </a:p>
+          <a:p>
+            <a:pPr>
+              <a:lnSpc>
+                <a:spcPct val="100000"/>
+              </a:lnSpc>
+            </a:pPr>
+            <a:endParaRPr lang="en-GB" sz="1500" b="0" u="none" strike="noStrike">
+              <a:solidFill>
+                <a:srgbClr val="000000"/>
+              </a:solidFill>
+              <a:effectLst/>
+              <a:uFillTx/>
+              <a:latin typeface="Arial"/>
+            </a:endParaRPr>
+          </a:p>
+          <a:p>
+            <a:pPr marL="285840" indent="-285840">
+              <a:lnSpc>
+                <a:spcPct val="100000"/>
+              </a:lnSpc>
+              <a:buClr>
+                <a:srgbClr val="FFFFFF"/>
+              </a:buClr>
+              <a:buFont typeface="OpenSymbol"/>
+              <a:buChar char="-"/>
+            </a:pPr>
+            <a:r>
+              <a:rPr lang="fr-FR" sz="1500" b="1" u="none" strike="noStrike">
+                <a:solidFill>
+                  <a:schemeClr val="lt1"/>
+                </a:solidFill>
+                <a:effectLst/>
+                <a:uFillTx/>
+                <a:latin typeface="Arial"/>
+              </a:rPr>
+              <a:t>Numéro de série unique (UID) : </a:t>
+            </a:r>
+            <a:r>
+              <a:rPr lang="fr-FR" sz="1500" b="0" u="none" strike="noStrike">
+                <a:solidFill>
+                  <a:schemeClr val="lt1"/>
+                </a:solidFill>
+                <a:effectLst/>
+                <a:uFillTx/>
+                <a:latin typeface="Arial"/>
+              </a:rPr>
+              <a:t>4C530000281008116284&amp;0</a:t>
+            </a:r>
+            <a:endParaRPr lang="en-GB" sz="1500" b="0" u="none" strike="noStrike">
+              <a:solidFill>
+                <a:srgbClr val="000000"/>
+              </a:solidFill>
+              <a:effectLst/>
+              <a:uFillTx/>
+              <a:latin typeface="Arial"/>
+            </a:endParaRPr>
+          </a:p>
+          <a:p>
+            <a:pPr>
+              <a:lnSpc>
+                <a:spcPct val="100000"/>
+              </a:lnSpc>
+            </a:pPr>
+            <a:endParaRPr lang="en-GB" sz="1500" b="0" u="none" strike="noStrike">
+              <a:solidFill>
+                <a:srgbClr val="000000"/>
+              </a:solidFill>
+              <a:effectLst/>
+              <a:uFillTx/>
+              <a:latin typeface="Arial"/>
+            </a:endParaRPr>
+          </a:p>
+          <a:p>
+            <a:pPr marL="285840" indent="-285840">
+              <a:lnSpc>
+                <a:spcPct val="100000"/>
+              </a:lnSpc>
+              <a:buClr>
+                <a:srgbClr val="FFFFFF"/>
+              </a:buClr>
+              <a:buFont typeface="OpenSymbol"/>
+              <a:buChar char="-"/>
+            </a:pPr>
+            <a:r>
+              <a:rPr lang="fr-FR" sz="1500" b="1" u="none" strike="noStrike">
+                <a:solidFill>
+                  <a:schemeClr val="lt1"/>
+                </a:solidFill>
+                <a:effectLst/>
+                <a:uFillTx/>
+                <a:latin typeface="Arial"/>
+              </a:rPr>
+              <a:t>Disk Id : </a:t>
+            </a:r>
+            <a:r>
+              <a:rPr lang="fr-FR" sz="1500" b="0" u="none" strike="noStrike">
+                <a:solidFill>
+                  <a:schemeClr val="lt1"/>
+                </a:solidFill>
+                <a:effectLst/>
+                <a:uFillTx/>
+                <a:latin typeface="Arial"/>
+              </a:rPr>
+              <a:t>{635b1203-467e-11ea-ba75-000c295e7ac0}</a:t>
+            </a:r>
+            <a:endParaRPr lang="en-GB" sz="1500" b="0" u="none" strike="noStrike">
+              <a:solidFill>
+                <a:srgbClr val="000000"/>
+              </a:solidFill>
+              <a:effectLst/>
+              <a:uFillTx/>
+              <a:latin typeface="Arial"/>
+            </a:endParaRPr>
+          </a:p>
+        </p:txBody>
+      </p:sp>
+      <p:pic>
+        <p:nvPicPr>
+          <p:cNvPr id="54" name="USBSTOR 54"/>
+          <p:cNvPicPr/>
+          <p:nvPr/>
+        </p:nvPicPr>
+        <p:blipFill>
+          <a:blip r:embed="rId1"/>
+          <a:stretch/>
+        </p:blipFill>
+        <p:spPr>
+          <a:xfrm>
+            <a:off x="596000" y="3700000"/>
+            <a:ext cx="11000000" cy="1488000"/>
+          </a:xfrm>
+          <a:prstGeom prst="rect">
+            <a:avLst/>
+          </a:prstGeom>
+          <a:noFill/>
+          <a:ln w="0">
+            <a:noFill/>
+          </a:ln>
+        </p:spPr>
+      </p:pic>
+      <p:sp>
+        <p:nvSpPr>
+          <p:cNvPr id="55" name="Legende 55"/>
+          <p:cNvSpPr/>
+          <p:nvPr/>
+        </p:nvSpPr>
+        <p:spPr>
+          <a:xfrm>
+            <a:off x="596000" y="5240000"/>
+            <a:ext cx="11000000" cy="250000"/>
+          </a:xfrm>
+          <a:prstGeom prst="rect">
+            <a:avLst/>
+          </a:prstGeom>
+          <a:noFill/>
+          <a:ln w="0">
+            <a:noFill/>
+          </a:ln>
+        </p:spPr>
+        <p:txBody>
+          <a:bodyPr lIns="0" tIns="0" rIns="0" bIns="0" anchor="t"/>
+          <a:p>
+            <a:pPr algn="ctr">
+              <a:buNone/>
+            </a:pPr>
+            <a:r>
+              <a:rPr lang="fr-FR" sz="1100" b="0" i="1" u="none" strike="noStrike">
+                <a:solidFill>
+                  <a:srgbClr val="B8C4D9"/>
+                </a:solidFill>
+                <a:effectLst/>
+                <a:uFillTx/>
+                <a:latin typeface="Arial"/>
+              </a:rPr>
+              <a:t>Clé USBSTOR : modèle, numéro de série et Disk Id</a:t>
+            </a:r>
           </a:p>
         </p:txBody>
       </p:sp>
@@ -3980,7 +4287,7 @@
       </p:grpSpPr>
       <p:sp>
         <p:nvSpPr>
-          <p:cNvPr id="55" name="PlaceHolder 1"/>
+          <p:cNvPr id="52" name="PlaceHolder 1"/>
           <p:cNvSpPr>
             <a:spLocks noGrp="1"/>
           </p:cNvSpPr>
@@ -4037,6 +4344,373 @@
               <a:uFillTx/>
               <a:latin typeface="Calibri"/>
             </a:endParaRPr>
+          </a:p>
+        </p:txBody>
+      </p:sp>
+      <p:sp>
+        <p:nvSpPr>
+          <p:cNvPr id="53" name="ZoneTexte 53"/>
+          <p:cNvSpPr/>
+          <p:nvPr/>
+        </p:nvSpPr>
+        <p:spPr>
+          <a:xfrm>
+            <a:off x="609480" y="1400000"/>
+            <a:ext cx="10900000" cy="2200000"/>
+          </a:xfrm>
+          <a:prstGeom prst="rect">
+            <a:avLst/>
+          </a:prstGeom>
+          <a:noFill/>
+          <a:ln w="0">
+            <a:noFill/>
+          </a:ln>
+        </p:spPr>
+        <p:style>
+          <a:lnRef idx="0"/>
+          <a:fillRef idx="0"/>
+          <a:effectRef idx="0"/>
+          <a:fontRef idx="minor"/>
+        </p:style>
+        <p:txBody>
+          <a:bodyPr lIns="90000" tIns="45000" rIns="90000" bIns="45000" anchor="t">
+            <a:spAutoFit/>
+          </a:bodyPr>
+          <a:p>
+            <a:pPr marL="285840" indent="-285840">
+              <a:lnSpc>
+                <a:spcPct val="100000"/>
+              </a:lnSpc>
+              <a:buClr>
+                <a:srgbClr val="FFFFFF"/>
+              </a:buClr>
+              <a:buFont typeface="OpenSymbol"/>
+              <a:buChar char="-"/>
+            </a:pPr>
+            <a:r>
+              <a:rPr lang="fr-FR" sz="1500" b="1" u="none" strike="noStrike">
+                <a:solidFill>
+                  <a:schemeClr val="lt1"/>
+                </a:solidFill>
+                <a:effectLst/>
+                <a:uFillTx/>
+                <a:latin typeface="Arial"/>
+              </a:rPr>
+              <a:t>Horodatages exploitables </a:t>
+            </a:r>
+            <a:r>
+              <a:rPr lang="fr-FR" sz="1500" b="0" u="none" strike="noStrike">
+                <a:solidFill>
+                  <a:schemeClr val="lt1"/>
+                </a:solidFill>
+                <a:effectLst/>
+                <a:uFillTx/>
+                <a:latin typeface="Arial"/>
+              </a:rPr>
+              <a:t>(clé USBSTOR, périphérique 4C530000281008116284&amp;0) :</a:t>
+            </a:r>
+            <a:endParaRPr lang="en-GB" sz="1500" b="0" u="none" strike="noStrike">
+              <a:solidFill>
+                <a:srgbClr val="000000"/>
+              </a:solidFill>
+              <a:effectLst/>
+              <a:uFillTx/>
+              <a:latin typeface="Arial"/>
+            </a:endParaRPr>
+          </a:p>
+          <a:p>
+            <a:pPr marL="285840" indent="-285840">
+              <a:lnSpc>
+                <a:spcPct val="100000"/>
+              </a:lnSpc>
+              <a:buClr>
+                <a:srgbClr val="FFFFFF"/>
+              </a:buClr>
+              <a:buFont typeface="OpenSymbol"/>
+              <a:buChar char="-"/>
+            </a:pPr>
+            <a:r>
+              <a:rPr lang="fr-FR" sz="1500" b="1" u="none" strike="noStrike">
+                <a:solidFill>
+                  <a:schemeClr val="lt1"/>
+                </a:solidFill>
+                <a:effectLst/>
+                <a:uFillTx/>
+                <a:latin typeface="Arial"/>
+              </a:rPr>
+              <a:t>First Installed : </a:t>
+            </a:r>
+            <a:r>
+              <a:rPr lang="fr-FR" sz="1500" b="0" u="none" strike="noStrike">
+                <a:solidFill>
+                  <a:schemeClr val="lt1"/>
+                </a:solidFill>
+                <a:effectLst/>
+                <a:uFillTx/>
+                <a:latin typeface="Arial"/>
+              </a:rPr>
+              <a:t>03/02/2020 à 12:12:32</a:t>
+            </a:r>
+            <a:endParaRPr lang="en-GB" sz="1500" b="0" u="none" strike="noStrike">
+              <a:solidFill>
+                <a:srgbClr val="000000"/>
+              </a:solidFill>
+              <a:effectLst/>
+              <a:uFillTx/>
+              <a:latin typeface="Arial"/>
+            </a:endParaRPr>
+          </a:p>
+          <a:p>
+            <a:pPr marL="285840" indent="-285840">
+              <a:lnSpc>
+                <a:spcPct val="100000"/>
+              </a:lnSpc>
+              <a:buClr>
+                <a:srgbClr val="FFFFFF"/>
+              </a:buClr>
+              <a:buFont typeface="OpenSymbol"/>
+              <a:buChar char="-"/>
+            </a:pPr>
+            <a:r>
+              <a:rPr lang="fr-FR" sz="1500" b="1" u="none" strike="noStrike">
+                <a:solidFill>
+                  <a:schemeClr val="lt1"/>
+                </a:solidFill>
+                <a:effectLst/>
+                <a:uFillTx/>
+                <a:latin typeface="Arial"/>
+              </a:rPr>
+              <a:t>Last Connected : </a:t>
+            </a:r>
+            <a:r>
+              <a:rPr lang="fr-FR" sz="1500" b="0" u="none" strike="noStrike">
+                <a:solidFill>
+                  <a:schemeClr val="lt1"/>
+                </a:solidFill>
+                <a:effectLst/>
+                <a:uFillTx/>
+                <a:latin typeface="Arial"/>
+              </a:rPr>
+              <a:t>03/02/2020 à 12:44:21</a:t>
+            </a:r>
+            <a:endParaRPr lang="en-GB" sz="1500" b="0" u="none" strike="noStrike">
+              <a:solidFill>
+                <a:srgbClr val="000000"/>
+              </a:solidFill>
+              <a:effectLst/>
+              <a:uFillTx/>
+              <a:latin typeface="Arial"/>
+            </a:endParaRPr>
+          </a:p>
+          <a:p>
+            <a:pPr marL="285840" indent="-285840">
+              <a:lnSpc>
+                <a:spcPct val="100000"/>
+              </a:lnSpc>
+              <a:buClr>
+                <a:srgbClr val="FFFFFF"/>
+              </a:buClr>
+              <a:buFont typeface="OpenSymbol"/>
+              <a:buChar char="-"/>
+            </a:pPr>
+            <a:r>
+              <a:rPr lang="fr-FR" sz="1500" b="1" u="none" strike="noStrike">
+                <a:solidFill>
+                  <a:schemeClr val="lt1"/>
+                </a:solidFill>
+                <a:effectLst/>
+                <a:uFillTx/>
+                <a:latin typeface="Arial"/>
+              </a:rPr>
+              <a:t>Last Removed : </a:t>
+            </a:r>
+            <a:r>
+              <a:rPr lang="fr-FR" sz="1500" b="0" u="none" strike="noStrike">
+                <a:solidFill>
+                  <a:schemeClr val="lt1"/>
+                </a:solidFill>
+                <a:effectLst/>
+                <a:uFillTx/>
+                <a:latin typeface="Arial"/>
+              </a:rPr>
+              <a:t>03/02/2020 à 12:45:00</a:t>
+            </a:r>
+            <a:endParaRPr lang="en-GB" sz="1500" b="0" u="none" strike="noStrike">
+              <a:solidFill>
+                <a:srgbClr val="000000"/>
+              </a:solidFill>
+              <a:effectLst/>
+              <a:uFillTx/>
+              <a:latin typeface="Arial"/>
+            </a:endParaRPr>
+          </a:p>
+          <a:p>
+            <a:pPr marL="285840" indent="-285840">
+              <a:lnSpc>
+                <a:spcPct val="100000"/>
+              </a:lnSpc>
+              <a:buClr>
+                <a:srgbClr val="FFFFFF"/>
+              </a:buClr>
+              <a:buFont typeface="OpenSymbol"/>
+              <a:buChar char="-"/>
+            </a:pPr>
+            <a:r>
+              <a:rPr lang="fr-FR" sz="1500" b="1" u="none" strike="noStrike">
+                <a:solidFill>
+                  <a:schemeClr val="lt1"/>
+                </a:solidFill>
+                <a:effectLst/>
+                <a:uFillTx/>
+                <a:latin typeface="Arial"/>
+              </a:rPr>
+              <a:t>Fenêtre d'utilisation : </a:t>
+            </a:r>
+            <a:r>
+              <a:rPr lang="fr-FR" sz="1500" b="0" u="none" strike="noStrike">
+                <a:solidFill>
+                  <a:schemeClr val="lt1"/>
+                </a:solidFill>
+                <a:effectLst/>
+                <a:uFillTx/>
+                <a:latin typeface="Arial"/>
+              </a:rPr>
+              <a:t>environ 32 minutes le 03/02/2020, à comparer aux dates supposées de fuite</a:t>
+            </a:r>
+            <a:endParaRPr lang="en-GB" sz="1500" b="0" u="none" strike="noStrike">
+              <a:solidFill>
+                <a:srgbClr val="000000"/>
+              </a:solidFill>
+              <a:effectLst/>
+              <a:uFillTx/>
+              <a:latin typeface="Arial"/>
+            </a:endParaRPr>
+          </a:p>
+        </p:txBody>
+      </p:sp>
+      <p:pic>
+        <p:nvPicPr>
+          <p:cNvPr id="54" name="Zoom 54"/>
+          <p:cNvPicPr/>
+          <p:nvPr/>
+        </p:nvPicPr>
+        <p:blipFill>
+          <a:blip r:embed="rId1"/>
+          <a:stretch/>
+        </p:blipFill>
+        <p:spPr>
+          <a:xfrm>
+            <a:off x="596000" y="3200000"/>
+            <a:ext cx="11000000" cy="545000"/>
+          </a:xfrm>
+          <a:prstGeom prst="rect">
+            <a:avLst/>
+          </a:prstGeom>
+          <a:noFill/>
+          <a:ln w="0">
+            <a:noFill/>
+          </a:ln>
+        </p:spPr>
+      </p:pic>
+      <p:sp>
+        <p:nvSpPr>
+          <p:cNvPr id="55" name="Legende 55"/>
+          <p:cNvSpPr/>
+          <p:nvPr/>
+        </p:nvSpPr>
+        <p:spPr>
+          <a:xfrm>
+            <a:off x="596000" y="3800000"/>
+            <a:ext cx="11000000" cy="250000"/>
+          </a:xfrm>
+          <a:prstGeom prst="rect">
+            <a:avLst/>
+          </a:prstGeom>
+          <a:noFill/>
+          <a:ln w="0">
+            <a:noFill/>
+          </a:ln>
+        </p:spPr>
+        <p:txBody>
+          <a:bodyPr lIns="0" tIns="0" rIns="0" bIns="0" anchor="t"/>
+          <a:p>
+            <a:pPr algn="ctr">
+              <a:buNone/>
+            </a:pPr>
+            <a:r>
+              <a:rPr lang="fr-FR" sz="1100" b="0" i="1" u="none" strike="noStrike">
+                <a:solidFill>
+                  <a:srgbClr val="B8C4D9"/>
+                </a:solidFill>
+                <a:effectLst/>
+                <a:uFillTx/>
+                <a:latin typeface="Arial"/>
+              </a:rPr>
+              <a:t>Zoom : horodatages complets de la clé USB</a:t>
+            </a:r>
+          </a:p>
+        </p:txBody>
+      </p:sp>
+      <p:pic>
+        <p:nvPicPr>
+          <p:cNvPr id="56" name="RegistryExplorer 56"/>
+          <p:cNvPicPr/>
+          <p:nvPr/>
+        </p:nvPicPr>
+        <p:blipFill>
+          <a:blip r:embed="rId2"/>
+          <a:stretch/>
+        </p:blipFill>
+        <p:spPr>
+          <a:xfrm>
+            <a:off x="2846000" y="4300000"/>
+            <a:ext cx="6500000" cy="1796000"/>
+          </a:xfrm>
+          <a:prstGeom prst="rect">
+            <a:avLst/>
+          </a:prstGeom>
+          <a:noFill/>
+          <a:ln w="0">
+            <a:noFill/>
+          </a:ln>
+        </p:spPr>
+      </p:pic>
+      <p:sp>
+        <p:nvSpPr>
+          <p:cNvPr id="57" name="Legende 57"/>
+          <p:cNvSpPr/>
+          <p:nvPr/>
+        </p:nvSpPr>
+        <p:spPr>
+          <a:xfrm>
+            <a:off x="2846000" y="6150000"/>
+            <a:ext cx="6500000" cy="250000"/>
+          </a:xfrm>
+          <a:prstGeom prst="rect">
+            <a:avLst/>
+          </a:prstGeom>
+          <a:noFill/>
+          <a:ln w="0">
+            <a:noFill/>
+          </a:ln>
+        </p:spPr>
+        <p:txBody>
+          <a:bodyPr lIns="0" tIns="0" rIns="0" bIns="0" anchor="t"/>
+          <a:p>
+            <a:pPr algn="ctr">
+              <a:buNone/>
+            </a:pPr>
+            <a:r>
+              <a:rPr lang="fr-FR" sz="1100" b="0" i="1" u="none" strike="noStrike">
+                <a:solidFill>
+                  <a:srgbClr val="B8C4D9"/>
+                </a:solidFill>
+                <a:effectLst/>
+                <a:uFillTx/>
+                <a:latin typeface="Arial"/>
+              </a:rPr>
+              <a:t>Clé USBSTOR dans Registry Explorer (ruche SYSTEM)</a:t>
+            </a:r>
           </a:p>
         </p:txBody>
       </p:sp>
@@ -6259,6 +6933,337 @@
           </a:p>
         </p:txBody>
       </p:sp>
+      <p:sp>
+        <p:nvSpPr>
+          <p:cNvPr id="53" name="ZoneTexte 53"/>
+          <p:cNvSpPr/>
+          <p:nvPr/>
+        </p:nvSpPr>
+        <p:spPr>
+          <a:xfrm>
+            <a:off x="609480" y="1500000"/>
+            <a:ext cx="5300000" cy="3250000"/>
+          </a:xfrm>
+          <a:prstGeom prst="rect">
+            <a:avLst/>
+          </a:prstGeom>
+          <a:noFill/>
+          <a:ln w="0">
+            <a:noFill/>
+          </a:ln>
+        </p:spPr>
+        <p:style>
+          <a:lnRef idx="0"/>
+          <a:fillRef idx="0"/>
+          <a:effectRef idx="0"/>
+          <a:fontRef idx="minor"/>
+        </p:style>
+        <p:txBody>
+          <a:bodyPr lIns="90000" tIns="45000" rIns="90000" bIns="45000" anchor="t">
+            <a:spAutoFit/>
+          </a:bodyPr>
+          <a:p>
+            <a:pPr marL="285840" indent="-285840">
+              <a:lnSpc>
+                <a:spcPct val="100000"/>
+              </a:lnSpc>
+              <a:buClr>
+                <a:srgbClr val="FFFFFF"/>
+              </a:buClr>
+              <a:buFont typeface="OpenSymbol"/>
+              <a:buChar char="-"/>
+            </a:pPr>
+            <a:r>
+              <a:rPr lang="fr-FR" sz="1500" b="1" u="none" strike="noStrike">
+                <a:solidFill>
+                  <a:schemeClr val="lt1"/>
+                </a:solidFill>
+                <a:effectLst/>
+                <a:uFillTx/>
+                <a:latin typeface="Arial"/>
+              </a:rPr>
+              <a:t>Outil : </a:t>
+            </a:r>
+            <a:r>
+              <a:rPr lang="fr-FR" sz="1500" b="0" u="none" strike="noStrike">
+                <a:solidFill>
+                  <a:schemeClr val="lt1"/>
+                </a:solidFill>
+                <a:effectLst/>
+                <a:uFillTx/>
+                <a:latin typeface="Arial"/>
+              </a:rPr>
+              <a:t>Exterro FTK Imager 8.3.0.27, image au format E01</a:t>
+            </a:r>
+            <a:endParaRPr lang="en-GB" sz="1500" b="0" u="none" strike="noStrike">
+              <a:solidFill>
+                <a:srgbClr val="000000"/>
+              </a:solidFill>
+              <a:effectLst/>
+              <a:uFillTx/>
+              <a:latin typeface="Arial"/>
+            </a:endParaRPr>
+          </a:p>
+          <a:p>
+            <a:pPr>
+              <a:lnSpc>
+                <a:spcPct val="100000"/>
+              </a:lnSpc>
+            </a:pPr>
+            <a:endParaRPr lang="en-GB" sz="1500" b="0" u="none" strike="noStrike">
+              <a:solidFill>
+                <a:srgbClr val="000000"/>
+              </a:solidFill>
+              <a:effectLst/>
+              <a:uFillTx/>
+              <a:latin typeface="Arial"/>
+            </a:endParaRPr>
+          </a:p>
+          <a:p>
+            <a:pPr marL="285840" indent="-285840">
+              <a:lnSpc>
+                <a:spcPct val="100000"/>
+              </a:lnSpc>
+              <a:buClr>
+                <a:srgbClr val="FFFFFF"/>
+              </a:buClr>
+              <a:buFont typeface="OpenSymbol"/>
+              <a:buChar char="-"/>
+            </a:pPr>
+            <a:r>
+              <a:rPr lang="fr-FR" sz="1500" b="1" u="none" strike="noStrike">
+                <a:solidFill>
+                  <a:schemeClr val="lt1"/>
+                </a:solidFill>
+                <a:effectLst/>
+                <a:uFillTx/>
+                <a:latin typeface="Arial"/>
+              </a:rPr>
+              <a:t>Image bit-à-bit : </a:t>
+            </a:r>
+            <a:r>
+              <a:rPr lang="fr-FR" sz="1500" b="0" u="none" strike="noStrike">
+                <a:solidFill>
+                  <a:schemeClr val="lt1"/>
+                </a:solidFill>
+                <a:effectLst/>
+                <a:uFillTx/>
+                <a:latin typeface="Arial"/>
+              </a:rPr>
+              <a:t>disque physique complet (PHYSICALDRIVE0), 125 829 120 secteurs, aucun bloc défectueux</a:t>
+            </a:r>
+            <a:endParaRPr lang="en-GB" sz="1500" b="0" u="none" strike="noStrike">
+              <a:solidFill>
+                <a:srgbClr val="000000"/>
+              </a:solidFill>
+              <a:effectLst/>
+              <a:uFillTx/>
+              <a:latin typeface="Arial"/>
+            </a:endParaRPr>
+          </a:p>
+          <a:p>
+            <a:pPr>
+              <a:lnSpc>
+                <a:spcPct val="100000"/>
+              </a:lnSpc>
+            </a:pPr>
+            <a:endParaRPr lang="en-GB" sz="1500" b="0" u="none" strike="noStrike">
+              <a:solidFill>
+                <a:srgbClr val="000000"/>
+              </a:solidFill>
+              <a:effectLst/>
+              <a:uFillTx/>
+              <a:latin typeface="Arial"/>
+            </a:endParaRPr>
+          </a:p>
+          <a:p>
+            <a:pPr marL="285840" indent="-285840">
+              <a:lnSpc>
+                <a:spcPct val="100000"/>
+              </a:lnSpc>
+              <a:buClr>
+                <a:srgbClr val="FFFFFF"/>
+              </a:buClr>
+              <a:buFont typeface="OpenSymbol"/>
+              <a:buChar char="-"/>
+            </a:pPr>
+            <a:r>
+              <a:rPr lang="fr-FR" sz="1500" b="1" u="none" strike="noStrike">
+                <a:solidFill>
+                  <a:schemeClr val="lt1"/>
+                </a:solidFill>
+                <a:effectLst/>
+                <a:uFillTx/>
+                <a:latin typeface="Arial"/>
+              </a:rPr>
+              <a:t>Intégrité vérifiée : </a:t>
+            </a:r>
+            <a:r>
+              <a:rPr lang="fr-FR" sz="1500" b="0" u="none" strike="noStrike">
+                <a:solidFill>
+                  <a:schemeClr val="lt1"/>
+                </a:solidFill>
+                <a:effectLst/>
+                <a:uFillTx/>
+                <a:latin typeface="Arial"/>
+              </a:rPr>
+              <a:t>MD5 et SHA1 concordants (Verify result : Match)</a:t>
+            </a:r>
+            <a:endParaRPr lang="en-GB" sz="1500" b="0" u="none" strike="noStrike">
+              <a:solidFill>
+                <a:srgbClr val="000000"/>
+              </a:solidFill>
+              <a:effectLst/>
+              <a:uFillTx/>
+              <a:latin typeface="Arial"/>
+            </a:endParaRPr>
+          </a:p>
+          <a:p>
+            <a:pPr>
+              <a:lnSpc>
+                <a:spcPct val="100000"/>
+              </a:lnSpc>
+            </a:pPr>
+            <a:endParaRPr lang="en-GB" sz="1500" b="0" u="none" strike="noStrike">
+              <a:solidFill>
+                <a:srgbClr val="000000"/>
+              </a:solidFill>
+              <a:effectLst/>
+              <a:uFillTx/>
+              <a:latin typeface="Arial"/>
+            </a:endParaRPr>
+          </a:p>
+          <a:p>
+            <a:pPr marL="285840" indent="-285840">
+              <a:lnSpc>
+                <a:spcPct val="100000"/>
+              </a:lnSpc>
+              <a:buClr>
+                <a:srgbClr val="FFFFFF"/>
+              </a:buClr>
+              <a:buFont typeface="OpenSymbol"/>
+              <a:buChar char="-"/>
+            </a:pPr>
+            <a:r>
+              <a:rPr lang="fr-FR" sz="1500" b="1" u="none" strike="noStrike">
+                <a:solidFill>
+                  <a:schemeClr val="lt1"/>
+                </a:solidFill>
+                <a:effectLst/>
+                <a:uFillTx/>
+                <a:latin typeface="Arial"/>
+              </a:rPr>
+              <a:t>Fichiers suspects : </a:t>
+            </a:r>
+            <a:r>
+              <a:rPr lang="fr-FR" sz="1500" b="0" u="none" strike="noStrike">
+                <a:solidFill>
+                  <a:schemeClr val="lt1"/>
+                </a:solidFill>
+                <a:effectLst/>
+                <a:uFillTx/>
+                <a:latin typeface="Arial"/>
+              </a:rPr>
+              <a:t>Env.exe (52 Ko) et Res.exe (25 Ko) retrouvés dans l'image avec les DLL Qt5 / MinGW</a:t>
+            </a:r>
+            <a:endParaRPr lang="en-GB" sz="1500" b="0" u="none" strike="noStrike">
+              <a:solidFill>
+                <a:srgbClr val="000000"/>
+              </a:solidFill>
+              <a:effectLst/>
+              <a:uFillTx/>
+              <a:latin typeface="Arial"/>
+            </a:endParaRPr>
+          </a:p>
+        </p:txBody>
+      </p:sp>
+      <p:pic>
+        <p:nvPicPr>
+          <p:cNvPr id="54" name="Verify 54"/>
+          <p:cNvPicPr/>
+          <p:nvPr/>
+        </p:nvPicPr>
+        <p:blipFill>
+          <a:blip r:embed="rId1"/>
+          <a:stretch/>
+        </p:blipFill>
+        <p:spPr>
+          <a:xfrm>
+            <a:off x="7175000" y="1450000"/>
+            <a:ext cx="3500000" cy="2293000"/>
+          </a:xfrm>
+          <a:prstGeom prst="rect">
+            <a:avLst/>
+          </a:prstGeom>
+          <a:noFill/>
+          <a:ln w="0">
+            <a:noFill/>
+          </a:ln>
+        </p:spPr>
+      </p:pic>
+      <p:pic>
+        <p:nvPicPr>
+          <p:cNvPr id="55" name="FTK 55"/>
+          <p:cNvPicPr/>
+          <p:nvPr/>
+        </p:nvPicPr>
+        <p:blipFill>
+          <a:blip r:embed="rId2"/>
+          <a:stretch/>
+        </p:blipFill>
+        <p:spPr>
+          <a:xfrm>
+            <a:off x="6250000" y="3950000"/>
+            <a:ext cx="5350000" cy="2179000"/>
+          </a:xfrm>
+          <a:prstGeom prst="rect">
+            <a:avLst/>
+          </a:prstGeom>
+          <a:noFill/>
+          <a:ln w="0">
+            <a:noFill/>
+          </a:ln>
+        </p:spPr>
+      </p:pic>
+      <p:sp>
+        <p:nvSpPr>
+          <p:cNvPr id="56" name="Legende 56"/>
+          <p:cNvSpPr/>
+          <p:nvPr/>
+        </p:nvSpPr>
+        <p:spPr>
+          <a:xfrm>
+            <a:off x="6250000" y="6180000"/>
+            <a:ext cx="5350000" cy="250000"/>
+          </a:xfrm>
+          <a:prstGeom prst="rect">
+            <a:avLst/>
+          </a:prstGeom>
+          <a:noFill/>
+          <a:ln w="0">
+            <a:noFill/>
+          </a:ln>
+        </p:spPr>
+        <p:txBody>
+          <a:bodyPr lIns="0" tIns="0" rIns="0" bIns="0" anchor="t"/>
+          <a:p>
+            <a:pPr algn="ctr">
+              <a:buNone/>
+            </a:pPr>
+            <a:r>
+              <a:rPr lang="fr-FR" sz="1100" b="0" i="1" u="none" strike="noStrike">
+                <a:solidFill>
+                  <a:srgbClr val="B8C4D9"/>
+                </a:solidFill>
+                <a:effectLst/>
+                <a:uFillTx/>
+                <a:latin typeface="Arial"/>
+              </a:rPr>
+              <a:t>Intégrité de l'image E01 et fichiers suspects localisés</a:t>
+            </a:r>
+          </a:p>
+        </p:txBody>
+      </p:sp>
     </p:spTree>
   </p:cSld>
   <mc:AlternateContent>
@@ -6291,7 +7296,7 @@
       </p:grpSpPr>
       <p:sp>
         <p:nvSpPr>
-          <p:cNvPr id="53" name="PlaceHolder 1"/>
+          <p:cNvPr id="52" name="PlaceHolder 1"/>
           <p:cNvSpPr>
             <a:spLocks noGrp="1"/>
           </p:cNvSpPr>
@@ -6348,6 +7353,313 @@
               <a:uFillTx/>
               <a:latin typeface="Calibri"/>
             </a:endParaRPr>
+          </a:p>
+        </p:txBody>
+      </p:sp>
+      <p:sp>
+        <p:nvSpPr>
+          <p:cNvPr id="53" name="ZoneTexte 53"/>
+          <p:cNvSpPr/>
+          <p:nvPr/>
+        </p:nvSpPr>
+        <p:spPr>
+          <a:xfrm>
+            <a:off x="609480" y="1400000"/>
+            <a:ext cx="10900000" cy="2900000"/>
+          </a:xfrm>
+          <a:prstGeom prst="rect">
+            <a:avLst/>
+          </a:prstGeom>
+          <a:noFill/>
+          <a:ln w="0">
+            <a:noFill/>
+          </a:ln>
+        </p:spPr>
+        <p:style>
+          <a:lnRef idx="0"/>
+          <a:fillRef idx="0"/>
+          <a:effectRef idx="0"/>
+          <a:fontRef idx="minor"/>
+        </p:style>
+        <p:txBody>
+          <a:bodyPr lIns="90000" tIns="45000" rIns="90000" bIns="45000" anchor="t">
+            <a:spAutoFit/>
+          </a:bodyPr>
+          <a:p>
+            <a:pPr marL="285840" indent="-285840">
+              <a:lnSpc>
+                <a:spcPct val="100000"/>
+              </a:lnSpc>
+              <a:buClr>
+                <a:srgbClr val="FFFFFF"/>
+              </a:buClr>
+              <a:buFont typeface="OpenSymbol"/>
+              <a:buChar char="-"/>
+            </a:pPr>
+            <a:r>
+              <a:rPr lang="fr-FR" sz="1500" b="1" u="none" strike="noStrike">
+                <a:solidFill>
+                  <a:schemeClr val="lt1"/>
+                </a:solidFill>
+                <a:effectLst/>
+                <a:uFillTx/>
+                <a:latin typeface="Arial"/>
+              </a:rPr>
+              <a:t>Outil : </a:t>
+            </a:r>
+            <a:r>
+              <a:rPr lang="fr-FR" sz="1500" b="0" u="none" strike="noStrike">
+                <a:solidFill>
+                  <a:schemeClr val="lt1"/>
+                </a:solidFill>
+                <a:effectLst/>
+                <a:uFillTx/>
+                <a:latin typeface="Arial"/>
+              </a:rPr>
+              <a:t>Volatility 3 (windows.pslist, netscan, registry.printkey) sur un dump mémoire de 5,86 Go acquis avec DumpIt</a:t>
+            </a:r>
+            <a:endParaRPr lang="en-GB" sz="1500" b="0" u="none" strike="noStrike">
+              <a:solidFill>
+                <a:srgbClr val="000000"/>
+              </a:solidFill>
+              <a:effectLst/>
+              <a:uFillTx/>
+              <a:latin typeface="Arial"/>
+            </a:endParaRPr>
+          </a:p>
+          <a:p>
+            <a:pPr>
+              <a:lnSpc>
+                <a:spcPct val="100000"/>
+              </a:lnSpc>
+            </a:pPr>
+            <a:endParaRPr lang="en-GB" sz="1500" b="0" u="none" strike="noStrike">
+              <a:solidFill>
+                <a:srgbClr val="000000"/>
+              </a:solidFill>
+              <a:effectLst/>
+              <a:uFillTx/>
+              <a:latin typeface="Arial"/>
+            </a:endParaRPr>
+          </a:p>
+          <a:p>
+            <a:pPr marL="285840" indent="-285840">
+              <a:lnSpc>
+                <a:spcPct val="100000"/>
+              </a:lnSpc>
+              <a:buClr>
+                <a:srgbClr val="FFFFFF"/>
+              </a:buClr>
+              <a:buFont typeface="OpenSymbol"/>
+              <a:buChar char="-"/>
+            </a:pPr>
+            <a:r>
+              <a:rPr lang="fr-FR" sz="1500" b="1" u="none" strike="noStrike">
+                <a:solidFill>
+                  <a:schemeClr val="lt1"/>
+                </a:solidFill>
+                <a:effectLst/>
+                <a:uFillTx/>
+                <a:latin typeface="Arial"/>
+              </a:rPr>
+              <a:t>Correspondance mémoire / disque : </a:t>
+            </a:r>
+            <a:r>
+              <a:rPr lang="fr-FR" sz="1500" b="0" u="none" strike="noStrike">
+                <a:solidFill>
+                  <a:schemeClr val="lt1"/>
+                </a:solidFill>
+                <a:effectLst/>
+                <a:uFillTx/>
+                <a:latin typeface="Arial"/>
+              </a:rPr>
+              <a:t>Res.exe (PID 7356) actif en mémoire, lancé par explorer.exe (PPID 3296) — même binaire que celui identifié sur l'image disque (US7)</a:t>
+            </a:r>
+            <a:endParaRPr lang="en-GB" sz="1500" b="0" u="none" strike="noStrike">
+              <a:solidFill>
+                <a:srgbClr val="000000"/>
+              </a:solidFill>
+              <a:effectLst/>
+              <a:uFillTx/>
+              <a:latin typeface="Arial"/>
+            </a:endParaRPr>
+          </a:p>
+          <a:p>
+            <a:pPr>
+              <a:lnSpc>
+                <a:spcPct val="100000"/>
+              </a:lnSpc>
+            </a:pPr>
+            <a:endParaRPr lang="en-GB" sz="1500" b="0" u="none" strike="noStrike">
+              <a:solidFill>
+                <a:srgbClr val="000000"/>
+              </a:solidFill>
+              <a:effectLst/>
+              <a:uFillTx/>
+              <a:latin typeface="Arial"/>
+            </a:endParaRPr>
+          </a:p>
+          <a:p>
+            <a:pPr marL="285840" indent="-285840">
+              <a:lnSpc>
+                <a:spcPct val="100000"/>
+              </a:lnSpc>
+              <a:buClr>
+                <a:srgbClr val="FFFFFF"/>
+              </a:buClr>
+              <a:buFont typeface="OpenSymbol"/>
+              <a:buChar char="-"/>
+            </a:pPr>
+            <a:r>
+              <a:rPr lang="fr-FR" sz="1500" b="1" u="none" strike="noStrike">
+                <a:solidFill>
+                  <a:schemeClr val="lt1"/>
+                </a:solidFill>
+                <a:effectLst/>
+                <a:uFillTx/>
+                <a:latin typeface="Arial"/>
+              </a:rPr>
+              <a:t>Persistance : </a:t>
+            </a:r>
+            <a:r>
+              <a:rPr lang="fr-FR" sz="1500" b="0" u="none" strike="noStrike">
+                <a:solidFill>
+                  <a:schemeClr val="lt1"/>
+                </a:solidFill>
+                <a:effectLst/>
+                <a:uFillTx/>
+                <a:latin typeface="Arial"/>
+              </a:rPr>
+              <a:t>aucune entrée liée au malware dans CurrentVersion\Run (seuls SecurityHealth et VMware User Process)</a:t>
+            </a:r>
+            <a:endParaRPr lang="en-GB" sz="1500" b="0" u="none" strike="noStrike">
+              <a:solidFill>
+                <a:srgbClr val="000000"/>
+              </a:solidFill>
+              <a:effectLst/>
+              <a:uFillTx/>
+              <a:latin typeface="Arial"/>
+            </a:endParaRPr>
+          </a:p>
+          <a:p>
+            <a:pPr>
+              <a:lnSpc>
+                <a:spcPct val="100000"/>
+              </a:lnSpc>
+            </a:pPr>
+            <a:endParaRPr lang="en-GB" sz="1500" b="0" u="none" strike="noStrike">
+              <a:solidFill>
+                <a:srgbClr val="000000"/>
+              </a:solidFill>
+              <a:effectLst/>
+              <a:uFillTx/>
+              <a:latin typeface="Arial"/>
+            </a:endParaRPr>
+          </a:p>
+          <a:p>
+            <a:pPr marL="285840" indent="-285840">
+              <a:lnSpc>
+                <a:spcPct val="100000"/>
+              </a:lnSpc>
+              <a:buClr>
+                <a:srgbClr val="FFFFFF"/>
+              </a:buClr>
+              <a:buFont typeface="OpenSymbol"/>
+              <a:buChar char="-"/>
+            </a:pPr>
+            <a:r>
+              <a:rPr lang="fr-FR" sz="1500" b="1" u="none" strike="noStrike">
+                <a:solidFill>
+                  <a:schemeClr val="lt1"/>
+                </a:solidFill>
+                <a:effectLst/>
+                <a:uFillTx/>
+                <a:latin typeface="Arial"/>
+              </a:rPr>
+              <a:t>Réseau : </a:t>
+            </a:r>
+            <a:r>
+              <a:rPr lang="fr-FR" sz="1500" b="0" u="none" strike="noStrike">
+                <a:solidFill>
+                  <a:schemeClr val="lt1"/>
+                </a:solidFill>
+                <a:effectLst/>
+                <a:uFillTx/>
+                <a:latin typeface="Arial"/>
+              </a:rPr>
+              <a:t>netscan ne remonte aucune connexion pour le PID 7356, cohérent avec l'absence de flux Wireshark (US4)</a:t>
+            </a:r>
+            <a:endParaRPr lang="en-GB" sz="1500" b="0" u="none" strike="noStrike">
+              <a:solidFill>
+                <a:srgbClr val="000000"/>
+              </a:solidFill>
+              <a:effectLst/>
+              <a:uFillTx/>
+              <a:latin typeface="Arial"/>
+            </a:endParaRPr>
+          </a:p>
+        </p:txBody>
+      </p:sp>
+      <p:pic>
+        <p:nvPicPr>
+          <p:cNvPr id="54" name="Volatility 54"/>
+          <p:cNvPicPr/>
+          <p:nvPr/>
+        </p:nvPicPr>
+        <p:blipFill>
+          <a:blip r:embed="rId1"/>
+          <a:stretch/>
+        </p:blipFill>
+        <p:spPr>
+          <a:xfrm>
+            <a:off x="1096000" y="3900000"/>
+            <a:ext cx="10000000" cy="1618000"/>
+          </a:xfrm>
+          <a:prstGeom prst="rect">
+            <a:avLst/>
+          </a:prstGeom>
+          <a:noFill/>
+          <a:ln w="0">
+            <a:noFill/>
+          </a:ln>
+        </p:spPr>
+      </p:pic>
+      <p:sp>
+        <p:nvSpPr>
+          <p:cNvPr id="55" name="Legende 55"/>
+          <p:cNvSpPr/>
+          <p:nvPr/>
+        </p:nvSpPr>
+        <p:spPr>
+          <a:xfrm>
+            <a:off x="1096000" y="5570000"/>
+            <a:ext cx="10000000" cy="250000"/>
+          </a:xfrm>
+          <a:prstGeom prst="rect">
+            <a:avLst/>
+          </a:prstGeom>
+          <a:noFill/>
+          <a:ln w="0">
+            <a:noFill/>
+          </a:ln>
+        </p:spPr>
+        <p:txBody>
+          <a:bodyPr lIns="0" tIns="0" rIns="0" bIns="0" anchor="t"/>
+          <a:p>
+            <a:pPr algn="ctr">
+              <a:buNone/>
+            </a:pPr>
+            <a:r>
+              <a:rPr lang="fr-FR" sz="1100" b="0" i="1" u="none" strike="noStrike">
+                <a:solidFill>
+                  <a:srgbClr val="B8C4D9"/>
+                </a:solidFill>
+                <a:effectLst/>
+                <a:uFillTx/>
+                <a:latin typeface="Arial"/>
+              </a:rPr>
+              <a:t>Res.exe présent en mémoire (pslist) et absent de netscan</a:t>
+            </a:r>
           </a:p>
         </p:txBody>
       </p:sp>

</xml_diff>